<commit_message>
docs: tira o foco de mim e devolve para a pratica
A primeira versao usava a primeira pessoa como sujeito das frases,
o que transformava boas praticas coletivas em autobiografia.

Reescrita: a pratica passa a ser o sujeito; a experiencia pessoal
aparece como evidencia pontual, nao como assunto.

- Titulos deixam de ser possessivos: 'Meu ciclo hoje' -> 'O ciclo',
  'O que eu nao faco com IA' -> 'Onde nao usar IA', 'Minha stack'
  -> 'Ferramentas', 'Como eu peco' -> 'Como pedir'
- Corpo passa ao imperativo: 'eu delego o tedioso' -> 'delegue o
  tedioso'; 'eu apago' -> 'apague'
- Secao 15 vira 'Metodo dentro da ferramenta', com a categoria como
  assunto e a ferramenta especifica movida para as notas
- Marcacao pessoal preservada onde ela sustenta o argumento: os tres
  erros do slide 3 e o atalho do slide 5 continuam declarados como meus

Co-Authored-By: Claude Opus 5 <noreply@anthropic.com>
</commit_message>
<xml_diff>
--- a/apresentacao/como-eu-uso-ia.pptx
+++ b/apresentacao/como-eu-uso-ia.pptx
@@ -1051,7 +1051,7 @@
           <a:p>
             <a:r>
               <a:rPr lang="en-US" dirty="0"/>
-              <a:t>Ponto honesto: o processo custa tokens a mais por sessao. O ganho aparece em nao refazer a tarefa.</a:t>
+              <a:t>Aqui vale dizer qual voce usa (Superpowers) — como exemplo, nao como recomendacao fechada. Ponto honesto: o processo custa tokens a mais por sessao; o ganho aparece em nao refazer a tarefa.</a:t>
             </a:r>
             <a:endParaRPr lang="en-US" dirty="0"/>
           </a:p>
@@ -2855,7 +2855,7 @@
                 <a:ea typeface="Calibri" pitchFamily="34" charset="-122"/>
                 <a:cs typeface="Calibri" pitchFamily="34" charset="-120"/>
               </a:rPr>
-              <a:t>O que mudou no meu jeito de trabalhar — e o que eu ainda erro</a:t>
+              <a:t>Práticas que funcionam — contadas pelo caminho que eu fiz até elas</a:t>
             </a:r>
             <a:endParaRPr lang="en-US" sz="1700" dirty="0"/>
           </a:p>
@@ -3144,7 +3144,7 @@
                 <a:ea typeface="Calibri" pitchFamily="34" charset="-122"/>
                 <a:cs typeface="Calibri" pitchFamily="34" charset="-120"/>
               </a:rPr>
-              <a:t>Ele escolhe — e devolve algo legítimo, com async, ORM trocado e assinatura nova.</a:t>
+              <a:t>O modelo escolhe — e devolve algo legítimo, com async, ORM trocado e assinatura nova.</a:t>
             </a:r>
             <a:endParaRPr lang="en-US" sz="1250" dirty="0"/>
           </a:p>
@@ -3647,7 +3647,7 @@
                 <a:ea typeface="Calibri" pitchFamily="34" charset="-122"/>
                 <a:cs typeface="Calibri" pitchFamily="34" charset="-120"/>
               </a:rPr>
-              <a:t>O parágrafo que mais me poupou retrabalho</a:t>
+              <a:t>O parágrafo que mais poupa retrabalho</a:t>
             </a:r>
             <a:endParaRPr lang="en-US" sz="1500" dirty="0"/>
           </a:p>
@@ -3935,7 +3935,7 @@
                 <a:ea typeface="Calibri" pitchFamily="34" charset="-122"/>
                 <a:cs typeface="Calibri" pitchFamily="34" charset="-120"/>
               </a:rPr>
-              <a:t>“Não mexe no serializers.py, é contrato público” — ele não tinha como saber.</a:t>
+              <a:t>“Não mexe no serializers.py, é contrato público” — o modelo não tinha como saber.</a:t>
             </a:r>
             <a:endParaRPr lang="en-US" sz="1300" dirty="0"/>
           </a:p>
@@ -3974,7 +3974,7 @@
                 <a:ea typeface="Calibri" pitchFamily="34" charset="-122"/>
                 <a:cs typeface="Calibri" pitchFamily="34" charset="-120"/>
               </a:rPr>
-              <a:t>Uso isso sempre que a tarefa passa de um arquivo.</a:t>
+              <a:t>Vale sempre que a tarefa passa de um arquivo.</a:t>
             </a:r>
             <a:endParaRPr lang="en-US" sz="1250" dirty="0"/>
           </a:p>
@@ -4163,7 +4163,7 @@
                 <a:ea typeface="Cambria" pitchFamily="34" charset="-122"/>
                 <a:cs typeface="Cambria" pitchFamily="34" charset="-120"/>
               </a:rPr>
-              <a:t>O que eu persisto</a:t>
+              <a:t>O que persistir</a:t>
             </a:r>
             <a:endParaRPr lang="en-US" sz="3800" dirty="0"/>
           </a:p>
@@ -4548,7 +4548,7 @@
                 <a:ea typeface="Calibri" pitchFamily="34" charset="-122"/>
                 <a:cs typeface="Calibri" pitchFamily="34" charset="-120"/>
               </a:rPr>
-              <a:t>Ele descobre isso em 2 segundos lendo o repo. Eu pago por essas linhas todo dia.</a:t>
+              <a:t>O modelo descobre isso em 2 segundos lendo o repo. E o time paga por essas linhas todo dia.</a:t>
             </a:r>
             <a:endParaRPr lang="en-US" sz="1300" dirty="0"/>
           </a:p>
@@ -4725,7 +4725,7 @@
                 <a:ea typeface="Calibri" pitchFamily="34" charset="-122"/>
                 <a:cs typeface="Calibri" pitchFamily="34" charset="-120"/>
               </a:rPr>
-              <a:t>Isso ele nunca descobre sozinho.</a:t>
+              <a:t>Isso nenhum modelo descobre sozinho.</a:t>
             </a:r>
             <a:endParaRPr lang="en-US" sz="1300" dirty="0"/>
           </a:p>
@@ -4764,7 +4764,7 @@
                 <a:ea typeface="Calibri" pitchFamily="34" charset="-122"/>
                 <a:cs typeface="Calibri" pitchFamily="34" charset="-120"/>
               </a:rPr>
-              <a:t>Teste: se a linha pode ser respondida lendo o README, eu apago.</a:t>
+              <a:t>Teste: se a linha pode ser respondida lendo o README, apague.</a:t>
             </a:r>
             <a:endParaRPr lang="en-US" sz="1600" dirty="0"/>
           </a:p>
@@ -4894,7 +4894,7 @@
                 <a:ea typeface="Cambria" pitchFamily="34" charset="-122"/>
                 <a:cs typeface="Cambria" pitchFamily="34" charset="-120"/>
               </a:rPr>
-              <a:t>Obsidian: onde guardo o que o código não conta</a:t>
+              <a:t>Onde mora o que o código não conta</a:t>
             </a:r>
             <a:endParaRPr lang="en-US" sz="3400" dirty="0"/>
           </a:p>
@@ -4902,18 +4902,57 @@
       </p:sp>
       <p:sp>
         <p:nvSpPr>
-          <p:cNvPr id="3" name="Shape 1"/>
-          <p:cNvSpPr/>
-          <p:nvPr/>
-        </p:nvSpPr>
-        <p:spPr>
-          <a:xfrm>
-            <a:off x="640080" y="1600200"/>
-            <a:ext cx="5349240" cy="2788920"/>
+          <p:cNvPr id="3" name="Text 1"/>
+          <p:cNvSpPr/>
+          <p:nvPr/>
+        </p:nvSpPr>
+        <p:spPr>
+          <a:xfrm>
+            <a:off x="640080" y="1298448"/>
+            <a:ext cx="10881360" cy="365760"/>
+          </a:xfrm>
+          <a:prstGeom prst="rect">
+            <a:avLst/>
+          </a:prstGeom>
+          <a:noFill/>
+          <a:ln/>
+        </p:spPr>
+        <p:txBody>
+          <a:bodyPr wrap="square" lIns="0" tIns="0" rIns="0" bIns="0" rtlCol="0" anchor="ctr"/>
+          <a:lstStyle/>
+          <a:p>
+            <a:pPr algn="l" indent="0" marL="0">
+              <a:buNone/>
+            </a:pPr>
+            <a:r>
+              <a:rPr lang="en-US" sz="1500" i="1" dirty="0">
+                <a:solidFill>
+                  <a:srgbClr val="6B7280"/>
+                </a:solidFill>
+                <a:latin typeface="Calibri" pitchFamily="34" charset="0"/>
+                <a:ea typeface="Calibri" pitchFamily="34" charset="-122"/>
+                <a:cs typeface="Calibri" pitchFamily="34" charset="-120"/>
+              </a:rPr>
+              <a:t>Vault de notas, wiki, ADR no repo — a ferramenta importa menos que o formato</a:t>
+            </a:r>
+            <a:endParaRPr lang="en-US" sz="1500" dirty="0"/>
+          </a:p>
+        </p:txBody>
+      </p:sp>
+      <p:sp>
+        <p:nvSpPr>
+          <p:cNvPr id="4" name="Shape 2"/>
+          <p:cNvSpPr/>
+          <p:nvPr/>
+        </p:nvSpPr>
+        <p:spPr>
+          <a:xfrm>
+            <a:off x="640080" y="1828800"/>
+            <a:ext cx="5349240" cy="2606040"/>
           </a:xfrm>
           <a:prstGeom prst="roundRect">
             <a:avLst>
-              <a:gd name="adj" fmla="val 2623"/>
+              <a:gd name="adj" fmla="val 2807"/>
             </a:avLst>
           </a:prstGeom>
           <a:solidFill>
@@ -4929,13 +4968,13 @@
       </p:sp>
       <p:sp>
         <p:nvSpPr>
-          <p:cNvPr id="4" name="Text 2"/>
-          <p:cNvSpPr/>
-          <p:nvPr/>
-        </p:nvSpPr>
-        <p:spPr>
-          <a:xfrm>
-            <a:off x="896112" y="1783080"/>
+          <p:cNvPr id="5" name="Text 3"/>
+          <p:cNvSpPr/>
+          <p:nvPr/>
+        </p:nvSpPr>
+        <p:spPr>
+          <a:xfrm>
+            <a:off x="896112" y="2011680"/>
             <a:ext cx="4837176" cy="347472"/>
           </a:xfrm>
           <a:prstGeom prst="rect">
@@ -4968,14 +5007,14 @@
       </p:sp>
       <p:sp>
         <p:nvSpPr>
-          <p:cNvPr id="5" name="Text 3"/>
-          <p:cNvSpPr/>
-          <p:nvPr/>
-        </p:nvSpPr>
-        <p:spPr>
-          <a:xfrm>
-            <a:off x="896112" y="2221992"/>
-            <a:ext cx="4837176" cy="1920240"/>
+          <p:cNvPr id="6" name="Text 4"/>
+          <p:cNvSpPr/>
+          <p:nvPr/>
+        </p:nvSpPr>
+        <p:spPr>
+          <a:xfrm>
+            <a:off x="896112" y="2450592"/>
+            <a:ext cx="4837176" cy="1737360"/>
           </a:xfrm>
           <a:prstGeom prst="rect">
             <a:avLst/>
@@ -5119,18 +5158,18 @@
       </p:sp>
       <p:sp>
         <p:nvSpPr>
-          <p:cNvPr id="6" name="Shape 4"/>
-          <p:cNvSpPr/>
-          <p:nvPr/>
-        </p:nvSpPr>
-        <p:spPr>
-          <a:xfrm>
-            <a:off x="6263640" y="1600200"/>
-            <a:ext cx="5349240" cy="2788920"/>
+          <p:cNvPr id="7" name="Shape 5"/>
+          <p:cNvSpPr/>
+          <p:nvPr/>
+        </p:nvSpPr>
+        <p:spPr>
+          <a:xfrm>
+            <a:off x="6263640" y="1828800"/>
+            <a:ext cx="5349240" cy="2606040"/>
           </a:xfrm>
           <a:prstGeom prst="roundRect">
             <a:avLst>
-              <a:gd name="adj" fmla="val 2623"/>
+              <a:gd name="adj" fmla="val 2807"/>
             </a:avLst>
           </a:prstGeom>
           <a:solidFill>
@@ -5146,13 +5185,13 @@
       </p:sp>
       <p:sp>
         <p:nvSpPr>
-          <p:cNvPr id="7" name="Text 5"/>
-          <p:cNvSpPr/>
-          <p:nvPr/>
-        </p:nvSpPr>
-        <p:spPr>
-          <a:xfrm>
-            <a:off x="6519672" y="1783080"/>
+          <p:cNvPr id="8" name="Text 6"/>
+          <p:cNvSpPr/>
+          <p:nvPr/>
+        </p:nvSpPr>
+        <p:spPr>
+          <a:xfrm>
+            <a:off x="6519672" y="2011680"/>
             <a:ext cx="4837176" cy="347472"/>
           </a:xfrm>
           <a:prstGeom prst="rect">
@@ -5185,14 +5224,14 @@
       </p:sp>
       <p:sp>
         <p:nvSpPr>
-          <p:cNvPr id="8" name="Text 6"/>
-          <p:cNvSpPr/>
-          <p:nvPr/>
-        </p:nvSpPr>
-        <p:spPr>
-          <a:xfrm>
-            <a:off x="6519672" y="2221992"/>
-            <a:ext cx="4837176" cy="1920240"/>
+          <p:cNvPr id="9" name="Text 7"/>
+          <p:cNvSpPr/>
+          <p:nvPr/>
+        </p:nvSpPr>
+        <p:spPr>
+          <a:xfrm>
+            <a:off x="6519672" y="2450592"/>
+            <a:ext cx="4837176" cy="1737360"/>
           </a:xfrm>
           <a:prstGeom prst="rect">
             <a:avLst/>
@@ -5334,13 +5373,13 @@
       </p:sp>
       <p:sp>
         <p:nvSpPr>
-          <p:cNvPr id="9" name="Text 7"/>
-          <p:cNvSpPr/>
-          <p:nvPr/>
-        </p:nvSpPr>
-        <p:spPr>
-          <a:xfrm>
-            <a:off x="640080" y="4617720"/>
+          <p:cNvPr id="10" name="Text 8"/>
+          <p:cNvSpPr/>
+          <p:nvPr/>
+        </p:nvSpPr>
+        <p:spPr>
+          <a:xfrm>
+            <a:off x="640080" y="4663440"/>
             <a:ext cx="10881360" cy="457200"/>
           </a:xfrm>
           <a:prstGeom prst="rect">
@@ -5373,7 +5412,7 @@
       </p:sp>
       <p:sp>
         <p:nvSpPr>
-          <p:cNvPr id="10" name="Shape 8"/>
+          <p:cNvPr id="11" name="Shape 9"/>
           <p:cNvSpPr/>
           <p:nvPr/>
         </p:nvSpPr>
@@ -5393,7 +5432,7 @@
       </p:sp>
       <p:sp>
         <p:nvSpPr>
-          <p:cNvPr id="11" name="Text 9"/>
+          <p:cNvPr id="12" name="Text 10"/>
           <p:cNvSpPr/>
           <p:nvPr/>
         </p:nvSpPr>
@@ -5495,7 +5534,7 @@
                 <a:ea typeface="Cambria" pitchFamily="34" charset="-122"/>
                 <a:cs typeface="Cambria" pitchFamily="34" charset="-120"/>
               </a:rPr>
-              <a:t>O que mais mudou meu resultado</a:t>
+              <a:t>Método dentro da ferramenta</a:t>
             </a:r>
             <a:endParaRPr lang="en-US" sz="3400" dirty="0"/>
           </a:p>
@@ -5534,7 +5573,7 @@
                 <a:ea typeface="Calibri" pitchFamily="34" charset="-122"/>
                 <a:cs typeface="Calibri" pitchFamily="34" charset="-120"/>
               </a:rPr>
-              <a:t>Não foi trocar de modelo. Foi colocar método dentro da ferramenta.</a:t>
+              <a:t>O que mais muda resultado não é trocar de modelo — é o ciclo deixar de ser opcional.</a:t>
             </a:r>
             <a:endParaRPr lang="en-US" sz="1600" dirty="0"/>
           </a:p>
@@ -5600,7 +5639,7 @@
                 <a:ea typeface="Calibri" pitchFamily="34" charset="-122"/>
                 <a:cs typeface="Calibri" pitchFamily="34" charset="-120"/>
               </a:rPr>
-              <a:t>Superpowers</a:t>
+              <a:t>Com framework</a:t>
             </a:r>
             <a:endParaRPr lang="en-US" sz="1600" dirty="0"/>
           </a:p>
@@ -5642,7 +5681,7 @@
                 <a:ea typeface="Calibri" pitchFamily="34" charset="-122"/>
                 <a:cs typeface="Calibri" pitchFamily="34" charset="-120"/>
               </a:rPr>
-              <a:t>Obriga o ciclo: entender → planejar → executar → verificar.</a:t>
+              <a:t>O ciclo é imposto: entender → planejar → executar → verificar.</a:t>
             </a:r>
             <a:endParaRPr lang="en-US" sz="1300" dirty="0"/>
           </a:p>
@@ -5728,7 +5767,7 @@
                 <a:ea typeface="Calibri" pitchFamily="34" charset="-122"/>
                 <a:cs typeface="Calibri" pitchFamily="34" charset="-120"/>
               </a:rPr>
-              <a:t>Sem ele</a:t>
+              <a:t>Sem framework</a:t>
             </a:r>
             <a:endParaRPr lang="en-US" sz="1600" dirty="0"/>
           </a:p>
@@ -5770,7 +5809,7 @@
                 <a:ea typeface="Calibri" pitchFamily="34" charset="-122"/>
                 <a:cs typeface="Calibri" pitchFamily="34" charset="-120"/>
               </a:rPr>
-              <a:t>Eu seguia o ciclo quando dava tempo.</a:t>
+              <a:t>O ciclo é seguido quando dá tempo.</a:t>
             </a:r>
             <a:endParaRPr lang="en-US" sz="1300" dirty="0"/>
           </a:p>
@@ -5790,7 +5829,7 @@
                 <a:ea typeface="Calibri" pitchFamily="34" charset="-122"/>
                 <a:cs typeface="Calibri" pitchFamily="34" charset="-120"/>
               </a:rPr>
-              <a:t>Sob prazo, era a primeira coisa que eu abandonava.</a:t>
+              <a:t>Sob prazo, é a primeira coisa a ser abandonada.</a:t>
             </a:r>
             <a:endParaRPr lang="en-US" sz="1300" dirty="0"/>
           </a:p>
@@ -5829,7 +5868,7 @@
                 <a:ea typeface="Cambria" pitchFamily="34" charset="-122"/>
                 <a:cs typeface="Cambria" pitchFamily="34" charset="-120"/>
               </a:rPr>
-              <a:t>A disciplina que depende de mim lembrar, sob prazo, não é disciplina.</a:t>
+              <a:t>Disciplina que depende de alguém lembrar, sob prazo, não é disciplina.</a:t>
             </a:r>
             <a:endParaRPr lang="en-US" sz="1900" dirty="0"/>
           </a:p>
@@ -6018,7 +6057,7 @@
                 <a:ea typeface="Cambria" pitchFamily="34" charset="-122"/>
                 <a:cs typeface="Cambria" pitchFamily="34" charset="-120"/>
               </a:rPr>
-              <a:t>Quando eu delego</a:t>
+              <a:t>Quando delegar</a:t>
             </a:r>
             <a:endParaRPr lang="en-US" sz="3800" dirty="0"/>
           </a:p>
@@ -6057,7 +6096,7 @@
                 <a:ea typeface="Calibri" pitchFamily="34" charset="-122"/>
                 <a:cs typeface="Calibri" pitchFamily="34" charset="-120"/>
               </a:rPr>
-              <a:t>Vocês usam agente autônomo. Aqui está o critério que eu aplicaria</a:t>
+              <a:t>O critério vale para qualquer agente autônomo — Devin ou outro</a:t>
             </a:r>
             <a:endParaRPr lang="en-US" sz="1600" dirty="0"/>
           </a:p>
@@ -6187,7 +6226,7 @@
                 <a:ea typeface="Cambria" pitchFamily="34" charset="-122"/>
                 <a:cs typeface="Cambria" pitchFamily="34" charset="-120"/>
               </a:rPr>
-              <a:t>Faço na mão · piloto · delego</a:t>
+              <a:t>Na mão · piloto · delega</a:t>
             </a:r>
             <a:endParaRPr lang="en-US" sz="3400" dirty="0"/>
           </a:p>
@@ -6226,7 +6265,7 @@
                 <a:ea typeface="Calibri" pitchFamily="34" charset="-122"/>
                 <a:cs typeface="Calibri" pitchFamily="34" charset="-120"/>
               </a:rPr>
-              <a:t>Decido isso antes de abrir a ferramenta, não depois</a:t>
+              <a:t>Decisão que vem antes de abrir a ferramenta, não depois</a:t>
             </a:r>
             <a:endParaRPr lang="en-US" sz="1500" dirty="0"/>
           </a:p>
@@ -6292,7 +6331,7 @@
                 <a:ea typeface="Calibri" pitchFamily="34" charset="-122"/>
                 <a:cs typeface="Calibri" pitchFamily="34" charset="-120"/>
               </a:rPr>
-              <a:t>FAÇO NA MÃO</a:t>
+              <a:t>NA MÃO</a:t>
             </a:r>
             <a:endParaRPr lang="en-US" sz="1500" dirty="0"/>
           </a:p>
@@ -6628,7 +6667,7 @@
                 <a:ea typeface="Calibri" pitchFamily="34" charset="-122"/>
                 <a:cs typeface="Calibri" pitchFamily="34" charset="-120"/>
               </a:rPr>
-              <a:t>DELEGO</a:t>
+              <a:t>DELEGA</a:t>
             </a:r>
             <a:endParaRPr lang="en-US" sz="1500" dirty="0"/>
           </a:p>
@@ -6769,7 +6808,7 @@
                 <a:ea typeface="Calibri" pitchFamily="34" charset="-122"/>
                 <a:cs typeface="Calibri" pitchFamily="34" charset="-120"/>
               </a:rPr>
-              <a:t>Delego o tedioso e verificável. Piloto o ambíguo. Faço na mão o irreversível.</a:t>
+              <a:t>Delegue o tedioso e verificável. Pilote o ambíguo. Faça na mão o irreversível.</a:t>
             </a:r>
             <a:endParaRPr lang="en-US" sz="1600" dirty="0"/>
           </a:p>
@@ -6808,7 +6847,7 @@
                 <a:ea typeface="Calibri" pitchFamily="34" charset="-122"/>
                 <a:cs typeface="Calibri" pitchFamily="34" charset="-120"/>
               </a:rPr>
-              <a:t>A pergunta que resolve quase tudo: existe teste que prova que ficou certo? Se não existe, não delego.</a:t>
+              <a:t>A pergunta que resolve quase tudo: existe teste que prova que ficou certo? Se não existe, não delegue.</a:t>
             </a:r>
             <a:endParaRPr lang="en-US" sz="1400" dirty="0"/>
           </a:p>
@@ -7404,7 +7443,7 @@
                 <a:ea typeface="Calibri" pitchFamily="34" charset="-122"/>
                 <a:cs typeface="Calibri" pitchFamily="34" charset="-120"/>
               </a:rPr>
-              <a:t>Meu atalho: git diff nos testes primeiro. Linha alterada em teste existente exige justificativa escrita.</a:t>
+              <a:t>Atalho: git diff nos testes primeiro. Linha alterada em teste existente exige justificativa escrita.</a:t>
             </a:r>
             <a:endParaRPr lang="en-US" sz="1400" dirty="0"/>
           </a:p>
@@ -7534,7 +7573,7 @@
                 <a:ea typeface="Cambria" pitchFamily="34" charset="-122"/>
                 <a:cs typeface="Cambria" pitchFamily="34" charset="-120"/>
               </a:rPr>
-              <a:t>O que eu não faço com IA</a:t>
+              <a:t>Onde não usar IA</a:t>
             </a:r>
             <a:endParaRPr lang="en-US" sz="3400" dirty="0"/>
           </a:p>
@@ -7713,7 +7752,7 @@
                 <a:ea typeface="Calibri" pitchFamily="34" charset="-122"/>
                 <a:cs typeface="Calibri" pitchFamily="34" charset="-120"/>
               </a:rPr>
-              <a:t>Ele estima a partir do texto. Peço a query — a máquina calcula, o número é auditável.</a:t>
+              <a:t>O modelo estima a partir do texto. Peça a query — a máquina calcula, o número é auditável.</a:t>
             </a:r>
             <a:endParaRPr lang="en-US" sz="1300" dirty="0"/>
           </a:p>
@@ -7853,7 +7892,7 @@
                 <a:ea typeface="Calibri" pitchFamily="34" charset="-122"/>
                 <a:cs typeface="Calibri" pitchFamily="34" charset="-120"/>
               </a:rPr>
-              <a:t>Uso para levantar alternativas. A escolha é minha, e é onde está o meu valor.</a:t>
+              <a:t>Serve para levantar alternativas. A escolha é da pessoa — e é onde está o valor dela.</a:t>
             </a:r>
             <a:endParaRPr lang="en-US" sz="1300" dirty="0"/>
           </a:p>
@@ -7951,7 +7990,7 @@
                 <a:ea typeface="Calibri" pitchFamily="34" charset="-122"/>
                 <a:cs typeface="Calibri" pitchFamily="34" charset="-120"/>
               </a:rPr>
-              <a:t>Aprovar o que não entendo</a:t>
+              <a:t>Aprovar o que não se entende</a:t>
             </a:r>
             <a:endParaRPr lang="en-US" sz="1500" dirty="0"/>
           </a:p>
@@ -7993,7 +8032,7 @@
                 <a:ea typeface="Calibri" pitchFamily="34" charset="-122"/>
                 <a:cs typeface="Calibri" pitchFamily="34" charset="-120"/>
               </a:rPr>
-              <a:t>Se não entendo cada linha, não aprovo. Dívida no dia 1, incidente no dia 90.</a:t>
+              <a:t>Se não entende cada linha, não aprove. Dívida no dia 1, incidente no dia 90.</a:t>
             </a:r>
             <a:endParaRPr lang="en-US" sz="1300" dirty="0"/>
           </a:p>
@@ -8133,7 +8172,7 @@
                 <a:ea typeface="Calibri" pitchFamily="34" charset="-122"/>
                 <a:cs typeface="Calibri" pitchFamily="34" charset="-120"/>
               </a:rPr>
-              <a:t>Nunca cola no prompt. Anonimizo ou uso dado sintético. Sem exceção de prazo.</a:t>
+              <a:t>Nunca no prompt. Anonimize ou use dado sintético. Sem exceção de prazo.</a:t>
             </a:r>
             <a:endParaRPr lang="en-US" sz="1300" dirty="0"/>
           </a:p>
@@ -8576,7 +8615,7 @@
                 <a:ea typeface="Calibri" pitchFamily="34" charset="-122"/>
                 <a:cs typeface="Calibri" pitchFamily="34" charset="-120"/>
               </a:rPr>
-              <a:t>Como eu trabalho hoje, na prática.</a:t>
+              <a:t>Práticas que funcionam, com exemplo real.</a:t>
             </a:r>
             <a:endParaRPr lang="en-US" sz="1350" dirty="0"/>
           </a:p>
@@ -8605,7 +8644,7 @@
                 <a:ea typeface="Calibri" pitchFamily="34" charset="-122"/>
                 <a:cs typeface="Calibri" pitchFamily="34" charset="-120"/>
               </a:rPr>
-              <a:t>O que me custou caro aprender.</a:t>
+              <a:t>O caminho até elas — que no meu caso foi caro.</a:t>
             </a:r>
             <a:endParaRPr lang="en-US" sz="1350" dirty="0"/>
           </a:p>
@@ -8634,7 +8673,7 @@
                 <a:ea typeface="Calibri" pitchFamily="34" charset="-122"/>
                 <a:cs typeface="Calibri" pitchFamily="34" charset="-120"/>
               </a:rPr>
-              <a:t>O que vocês podem roubar de mim já na segunda.</a:t>
+              <a:t>O que dá para aplicar já na segunda.</a:t>
             </a:r>
             <a:endParaRPr lang="en-US" sz="1350" dirty="0"/>
           </a:p>
@@ -8673,7 +8712,7 @@
                 <a:ea typeface="Calibri" pitchFamily="34" charset="-122"/>
                 <a:cs typeface="Calibri" pitchFamily="34" charset="-120"/>
               </a:rPr>
-              <a:t>Se no fim vocês discordarem de mim, ótimo — é para isso que reservei metade do tempo.</a:t>
+              <a:t>Se no fim vocês discordarem, ótimo — é para isso que metade do tempo está reservada.</a:t>
             </a:r>
             <a:endParaRPr lang="en-US" sz="1600" dirty="0"/>
           </a:p>
@@ -8803,7 +8842,7 @@
                 <a:ea typeface="Cambria" pitchFamily="34" charset="-122"/>
                 <a:cs typeface="Cambria" pitchFamily="34" charset="-120"/>
               </a:rPr>
-              <a:t>Minha stack, rápido</a:t>
+              <a:t>Ferramentas, rápido</a:t>
             </a:r>
             <a:endParaRPr lang="en-US" sz="3400" dirty="0"/>
           </a:p>
@@ -8842,7 +8881,7 @@
                 <a:ea typeface="Calibri" pitchFamily="34" charset="-122"/>
                 <a:cs typeface="Calibri" pitchFamily="34" charset="-120"/>
               </a:rPr>
-              <a:t>Menos importante do que tudo que veio antes — mas sempre perguntam</a:t>
+              <a:t>O que eu uso hoje. Menos importante que tudo que veio antes — mas sempre perguntam</a:t>
             </a:r>
             <a:endParaRPr lang="en-US" sz="1500" dirty="0"/>
           </a:p>
@@ -8947,7 +8986,7 @@
                 <a:ea typeface="Calibri" pitchFamily="34" charset="-122"/>
                 <a:cs typeface="Calibri" pitchFamily="34" charset="-120"/>
               </a:rPr>
-              <a:t>onde eu trabalho</a:t>
+              <a:t>onde o trabalho acontece</a:t>
             </a:r>
             <a:endParaRPr lang="en-US" sz="1350" dirty="0"/>
           </a:p>
@@ -9052,7 +9091,7 @@
                 <a:ea typeface="Calibri" pitchFamily="34" charset="-122"/>
                 <a:cs typeface="Calibri" pitchFamily="34" charset="-120"/>
               </a:rPr>
-              <a:t>impõe o ciclo; a que mais mudou meu resultado</a:t>
+              <a:t>framework de processo: impõe o ciclo dentro da ferramenta</a:t>
             </a:r>
             <a:endParaRPr lang="en-US" sz="1350" dirty="0"/>
           </a:p>
@@ -9431,7 +9470,7 @@
                 <a:ea typeface="Cambria" pitchFamily="34" charset="-122"/>
                 <a:cs typeface="Cambria" pitchFamily="34" charset="-120"/>
               </a:rPr>
-              <a:t>Se vocês pegarem três coisas daqui</a:t>
+              <a:t>Três coisas para segunda-feira</a:t>
             </a:r>
             <a:endParaRPr lang="en-US" sz="3400" dirty="0"/>
           </a:p>
@@ -10240,7 +10279,7 @@
                 <a:ea typeface="Calibri" pitchFamily="34" charset="-122"/>
                 <a:cs typeface="Calibri" pitchFamily="34" charset="-120"/>
               </a:rPr>
-              <a:t>O que vocês já fazem que eu deveria copiar?</a:t>
+              <a:t>O que vocês já fazem que o resto do time deveria copiar?</a:t>
             </a:r>
             <a:endParaRPr lang="en-US" sz="1500" dirty="0"/>
           </a:p>
@@ -10371,7 +10410,7 @@
                 <a:ea typeface="Cambria" pitchFamily="34" charset="-122"/>
                 <a:cs typeface="Cambria" pitchFamily="34" charset="-120"/>
               </a:rPr>
-              <a:t>Começo pelo que eu fazia errado</a:t>
+              <a:t>Três erros que custam caro</a:t>
             </a:r>
             <a:endParaRPr lang="en-US" sz="3400" dirty="0"/>
           </a:p>
@@ -10410,7 +10449,7 @@
                 <a:ea typeface="Calibri" pitchFamily="34" charset="-122"/>
                 <a:cs typeface="Calibri" pitchFamily="34" charset="-120"/>
               </a:rPr>
-              <a:t>Os três erros que me custaram mais tempo</a:t>
+              <a:t>Os três eram meus. Pela conversa com outras squads, não eram só meus.</a:t>
             </a:r>
             <a:endParaRPr lang="en-US" sz="1500" dirty="0"/>
           </a:p>
@@ -10508,7 +10547,7 @@
                 <a:ea typeface="Calibri" pitchFamily="34" charset="-122"/>
                 <a:cs typeface="Calibri" pitchFamily="34" charset="-120"/>
               </a:rPr>
-              <a:t>Colava tudo</a:t>
+              <a:t>Colar tudo</a:t>
             </a:r>
             <a:endParaRPr lang="en-US" sz="1700" dirty="0"/>
           </a:p>
@@ -10570,7 +10609,7 @@
                 <a:ea typeface="Calibri" pitchFamily="34" charset="-122"/>
                 <a:cs typeface="Calibri" pitchFamily="34" charset="-120"/>
               </a:rPr>
-              <a:t>Achava que mais contexto = melhor resposta.</a:t>
+              <a:t>A intuição de que mais contexto = melhor resposta.</a:t>
             </a:r>
             <a:endParaRPr lang="en-US" sz="1350" dirty="0"/>
           </a:p>
@@ -10668,7 +10707,7 @@
                 <a:ea typeface="Calibri" pitchFamily="34" charset="-122"/>
                 <a:cs typeface="Calibri" pitchFamily="34" charset="-120"/>
               </a:rPr>
-              <a:t>Pedia vago</a:t>
+              <a:t>Pedir vago</a:t>
             </a:r>
             <a:endParaRPr lang="en-US" sz="1700" dirty="0"/>
           </a:p>
@@ -10730,7 +10769,7 @@
                 <a:ea typeface="Calibri" pitchFamily="34" charset="-122"/>
                 <a:cs typeface="Calibri" pitchFamily="34" charset="-120"/>
               </a:rPr>
-              <a:t>Recebia algo legítimo que eu não podia usar.</a:t>
+              <a:t>Volta algo legítimo que não dá para usar.</a:t>
             </a:r>
             <a:endParaRPr lang="en-US" sz="1350" dirty="0"/>
           </a:p>
@@ -10828,7 +10867,7 @@
                 <a:ea typeface="Calibri" pitchFamily="34" charset="-122"/>
                 <a:cs typeface="Calibri" pitchFamily="34" charset="-120"/>
               </a:rPr>
-              <a:t>Aceitava o que vinha</a:t>
+              <a:t>Aceitar o que vem</a:t>
             </a:r>
             <a:endParaRPr lang="en-US" sz="1700" dirty="0"/>
           </a:p>
@@ -10870,7 +10909,7 @@
                 <a:ea typeface="Calibri" pitchFamily="34" charset="-122"/>
                 <a:cs typeface="Calibri" pitchFamily="34" charset="-120"/>
               </a:rPr>
-              <a:t>Estava bem escrito, parecia certo.</a:t>
+              <a:t>Bem escrito, parece certo, ninguém roda.</a:t>
             </a:r>
             <a:endParaRPr lang="en-US" sz="1350" dirty="0"/>
           </a:p>
@@ -10890,7 +10929,7 @@
                 <a:ea typeface="Calibri" pitchFamily="34" charset="-122"/>
                 <a:cs typeface="Calibri" pitchFamily="34" charset="-120"/>
               </a:rPr>
-              <a:t>Eu não rodava. Descobria no review — ou em produção.</a:t>
+              <a:t>Aparece no review — ou em produção.</a:t>
             </a:r>
             <a:endParaRPr lang="en-US" sz="1350" dirty="0"/>
           </a:p>
@@ -10929,7 +10968,7 @@
                 <a:ea typeface="Calibri" pitchFamily="34" charset="-122"/>
                 <a:cs typeface="Calibri" pitchFamily="34" charset="-120"/>
               </a:rPr>
-              <a:t>Nenhum desses erros é sobre a ferramenta. Os três são sobre mim.</a:t>
+              <a:t>Nenhum dos três é sobre a ferramenta. Os três são sobre método.</a:t>
             </a:r>
             <a:endParaRPr lang="en-US" sz="1250" dirty="0"/>
           </a:p>
@@ -11035,7 +11074,7 @@
         <p:spPr>
           <a:xfrm>
             <a:off x="640080" y="1051560"/>
-            <a:ext cx="7315200" cy="731520"/>
+            <a:ext cx="9144000" cy="731520"/>
           </a:xfrm>
           <a:prstGeom prst="rect">
             <a:avLst/>
@@ -11059,7 +11098,7 @@
                 <a:ea typeface="Cambria" pitchFamily="34" charset="-122"/>
                 <a:cs typeface="Cambria" pitchFamily="34" charset="-120"/>
               </a:rPr>
-              <a:t>A virada</a:t>
+              <a:t>O gargalo mudou de lugar</a:t>
             </a:r>
             <a:endParaRPr lang="en-US" sz="3400" dirty="0"/>
           </a:p>
@@ -11098,7 +11137,7 @@
                 <a:ea typeface="Cambria" pitchFamily="34" charset="-122"/>
                 <a:cs typeface="Cambria" pitchFamily="34" charset="-120"/>
               </a:rPr>
-              <a:t>Escrever código deixou de ser o meu gargalo.</a:t>
+              <a:t>Escrever código deixou de ser o gargalo.</a:t>
             </a:r>
             <a:endParaRPr lang="en-US" sz="2700" dirty="0"/>
           </a:p>
@@ -11179,7 +11218,7 @@
                 <a:ea typeface="Calibri" pitchFamily="34" charset="-122"/>
                 <a:cs typeface="Calibri" pitchFamily="34" charset="-120"/>
               </a:rPr>
-              <a:t>Quando eu não decido, o modelo decide por mim — por omissão, com confiança, e eu só descubro no code review.</a:t>
+              <a:t>Quando ninguém decide, o modelo decide — por omissão, com confiança. E isso só aparece no code review.</a:t>
             </a:r>
             <a:endParaRPr lang="en-US" sz="1600" dirty="0"/>
           </a:p>
@@ -11309,7 +11348,7 @@
                 <a:ea typeface="Cambria" pitchFamily="34" charset="-122"/>
                 <a:cs typeface="Cambria" pitchFamily="34" charset="-120"/>
               </a:rPr>
-              <a:t>Meu ciclo hoje</a:t>
+              <a:t>O ciclo</a:t>
             </a:r>
             <a:endParaRPr lang="en-US" sz="3400" dirty="0"/>
           </a:p>
@@ -11414,7 +11453,7 @@
                 <a:ea typeface="Calibri" pitchFamily="34" charset="-122"/>
                 <a:cs typeface="Calibri" pitchFamily="34" charset="-120"/>
               </a:rPr>
-              <a:t>ENTENDO</a:t>
+              <a:t>ENTENDER</a:t>
             </a:r>
             <a:endParaRPr lang="en-US" sz="1300" dirty="0"/>
           </a:p>
@@ -11456,7 +11495,7 @@
                 <a:ea typeface="Calibri" pitchFamily="34" charset="-122"/>
                 <a:cs typeface="Calibri" pitchFamily="34" charset="-120"/>
               </a:rPr>
-              <a:t>leio antes</a:t>
+              <a:t>ler antes</a:t>
             </a:r>
             <a:endParaRPr lang="en-US" sz="1150" dirty="0"/>
           </a:p>
@@ -11581,7 +11620,7 @@
                 <a:ea typeface="Calibri" pitchFamily="34" charset="-122"/>
                 <a:cs typeface="Calibri" pitchFamily="34" charset="-120"/>
               </a:rPr>
-              <a:t>ESPECIFICO</a:t>
+              <a:t>ESPECIFICAR</a:t>
             </a:r>
             <a:endParaRPr lang="en-US" sz="1300" dirty="0"/>
           </a:p>
@@ -11623,7 +11662,7 @@
                 <a:ea typeface="Calibri" pitchFamily="34" charset="-122"/>
                 <a:cs typeface="Calibri" pitchFamily="34" charset="-120"/>
               </a:rPr>
-              <a:t>escrevo o</a:t>
+              <a:t>escrever o</a:t>
             </a:r>
             <a:endParaRPr lang="en-US" sz="1150" dirty="0"/>
           </a:p>
@@ -11748,7 +11787,7 @@
                 <a:ea typeface="Calibri" pitchFamily="34" charset="-122"/>
                 <a:cs typeface="Calibri" pitchFamily="34" charset="-120"/>
               </a:rPr>
-              <a:t>EXECUTO</a:t>
+              <a:t>EXECUTAR</a:t>
             </a:r>
             <a:endParaRPr lang="en-US" sz="1300" dirty="0"/>
           </a:p>
@@ -11790,7 +11829,7 @@
                 <a:ea typeface="Calibri" pitchFamily="34" charset="-122"/>
                 <a:cs typeface="Calibri" pitchFamily="34" charset="-120"/>
               </a:rPr>
-              <a:t>eu ou o</a:t>
+              <a:t>pessoa ou</a:t>
             </a:r>
             <a:endParaRPr lang="en-US" sz="1150" dirty="0"/>
           </a:p>
@@ -11915,7 +11954,7 @@
                 <a:ea typeface="Calibri" pitchFamily="34" charset="-122"/>
                 <a:cs typeface="Calibri" pitchFamily="34" charset="-120"/>
               </a:rPr>
-              <a:t>VERIFICO</a:t>
+              <a:t>VERIFICAR</a:t>
             </a:r>
             <a:endParaRPr lang="en-US" sz="1300" dirty="0"/>
           </a:p>
@@ -11957,7 +11996,7 @@
                 <a:ea typeface="Calibri" pitchFamily="34" charset="-122"/>
                 <a:cs typeface="Calibri" pitchFamily="34" charset="-120"/>
               </a:rPr>
-              <a:t>rodo, não</a:t>
+              <a:t>rodar, não</a:t>
             </a:r>
             <a:endParaRPr lang="en-US" sz="1150" dirty="0"/>
           </a:p>
@@ -11977,7 +12016,7 @@
                 <a:ea typeface="Calibri" pitchFamily="34" charset="-122"/>
                 <a:cs typeface="Calibri" pitchFamily="34" charset="-120"/>
               </a:rPr>
-              <a:t>leio</a:t>
+              <a:t>ler</a:t>
             </a:r>
             <a:endParaRPr lang="en-US" sz="1150" dirty="0"/>
           </a:p>
@@ -12082,7 +12121,7 @@
                 <a:ea typeface="Calibri" pitchFamily="34" charset="-122"/>
                 <a:cs typeface="Calibri" pitchFamily="34" charset="-120"/>
               </a:rPr>
-              <a:t>REGISTRO</a:t>
+              <a:t>REGISTRAR</a:t>
             </a:r>
             <a:endParaRPr lang="en-US" sz="1300" dirty="0"/>
           </a:p>
@@ -12183,7 +12222,7 @@
                 <a:ea typeface="Calibri" pitchFamily="34" charset="-122"/>
                 <a:cs typeface="Calibri" pitchFamily="34" charset="-120"/>
               </a:rPr>
-              <a:t>A etapa 2 é a que eu mais pulava — e é a única que, quando falha, estraga todas as outras.</a:t>
+              <a:t>A etapa 2 é a que mais se pula — e a única que, quando falha, estraga todas as outras.</a:t>
             </a:r>
             <a:endParaRPr lang="en-US" sz="1550" dirty="0"/>
           </a:p>
@@ -12222,7 +12261,7 @@
                 <a:ea typeface="Calibri" pitchFamily="34" charset="-122"/>
                 <a:cs typeface="Calibri" pitchFamily="34" charset="-120"/>
               </a:rPr>
-              <a:t>Antes: eu ia direto de “tenho um problema” para “escreve o código”.</a:t>
+              <a:t>O atalho comum — e o meu, por muito tempo: pular de “tenho um problema” direto para “escreve o código”.</a:t>
             </a:r>
             <a:endParaRPr lang="en-US" sz="1250" dirty="0"/>
           </a:p>
@@ -12450,7 +12489,7 @@
                 <a:ea typeface="Calibri" pitchFamily="34" charset="-122"/>
                 <a:cs typeface="Calibri" pitchFamily="34" charset="-120"/>
               </a:rPr>
-              <a:t>A parte que acontece antes de eu digitar qualquer coisa</a:t>
+              <a:t>A parte que acontece antes de digitar qualquer coisa</a:t>
             </a:r>
             <a:endParaRPr lang="en-US" sz="1600" dirty="0"/>
           </a:p>
@@ -12646,7 +12685,7 @@
                 <a:ea typeface="Calibri" pitchFamily="34" charset="-122"/>
                 <a:cs typeface="Calibri" pitchFamily="34" charset="-120"/>
               </a:rPr>
-              <a:t>✕  Como eu fazia</a:t>
+              <a:t>✕  Sem recorte</a:t>
             </a:r>
             <a:endParaRPr lang="en-US" sz="1500" dirty="0"/>
           </a:p>
@@ -12863,7 +12902,7 @@
                 <a:ea typeface="Calibri" pitchFamily="34" charset="-122"/>
                 <a:cs typeface="Calibri" pitchFamily="34" charset="-120"/>
               </a:rPr>
-              <a:t>✓  Como eu faço</a:t>
+              <a:t>✓  Com recorte</a:t>
             </a:r>
             <a:endParaRPr lang="en-US" sz="1500" dirty="0"/>
           </a:p>
@@ -13365,7 +13404,7 @@
                 <a:ea typeface="Calibri" pitchFamily="34" charset="-122"/>
                 <a:cs typeface="Calibri" pitchFamily="34" charset="-120"/>
               </a:rPr>
-              <a:t>O que eu peço antes de abrir sessão nova:</a:t>
+              <a:t>O que pedir antes de abrir uma sessão nova:</a:t>
             </a:r>
             <a:endParaRPr lang="en-US" sz="1400" dirty="0"/>
           </a:p>
@@ -13508,7 +13547,7 @@
                 <a:ea typeface="Calibri" pitchFamily="34" charset="-122"/>
                 <a:cs typeface="Calibri" pitchFamily="34" charset="-120"/>
               </a:rPr>
-              <a:t>O bloco de decisões descartadas é o que mais me economiza: sem ele, a sessão nova propõe de novo tudo que eu já tinha recusado.</a:t>
+              <a:t>O bloco de decisões descartadas é o que mais economiza: sem ele, a sessão nova propõe de novo tudo que já tinha sido recusado.</a:t>
             </a:r>
             <a:endParaRPr lang="en-US" sz="1450" dirty="0"/>
           </a:p>
@@ -13697,7 +13736,7 @@
                 <a:ea typeface="Cambria" pitchFamily="34" charset="-122"/>
                 <a:cs typeface="Cambria" pitchFamily="34" charset="-120"/>
               </a:rPr>
-              <a:t>Como eu peço</a:t>
+              <a:t>Como pedir</a:t>
             </a:r>
             <a:endParaRPr lang="en-US" sz="3800" dirty="0"/>
           </a:p>
@@ -13736,7 +13775,7 @@
                 <a:ea typeface="Calibri" pitchFamily="34" charset="-122"/>
                 <a:cs typeface="Calibri" pitchFamily="34" charset="-120"/>
               </a:rPr>
-              <a:t>Onde eu mais mudei — e onde o retorno é mais rápido</a:t>
+              <a:t>Onde o retorno aparece mais rápido</a:t>
             </a:r>
             <a:endParaRPr lang="en-US" sz="1600" dirty="0"/>
           </a:p>

</xml_diff>